<commit_message>
v2.1: Sync E drive canonical repo
</commit_message>
<xml_diff>
--- a/04_图表/TB_Incidence_Divergence_Figures_Tables.pptx
+++ b/04_图表/TB_Incidence_Divergence_Figures_Tables.pptx
@@ -15,6 +15,7 @@
     <p:sldId id="263" r:id="rId14"/>
     <p:sldId id="264" r:id="rId15"/>
     <p:sldId id="265" r:id="rId16"/>
+    <p:sldId id="266" r:id="rId17"/>
   </p:sldIdLst>
   <p:sldSz cx="7560000" cy="10692000" type="screen4x3"/>
   <p:notesSz cx="6858000" cy="9144000"/>
@@ -7498,6 +7499,58 @@
 </p:sld>
 </file>
 
+<file path=ppt/slides/slide11.xml><?xml version="1.0" encoding="utf-8"?>
+<p:sld xmlns:a="http://schemas.openxmlformats.org/drawingml/2006/main" xmlns:p="http://schemas.openxmlformats.org/presentationml/2006/main" xmlns:r="http://schemas.openxmlformats.org/officeDocument/2006/relationships">
+  <p:cSld>
+    <p:spTree>
+      <p:nvGrpSpPr>
+        <p:cNvPr id="1" name=""/>
+        <p:cNvGrpSpPr/>
+        <p:nvPr/>
+      </p:nvGrpSpPr>
+      <p:grpSpPr/>
+      <p:sp>
+        <p:nvSpPr>
+          <p:cNvPr id="2" name="TextBox 1"/>
+          <p:cNvSpPr txBox="1"/>
+          <p:nvPr/>
+        </p:nvSpPr>
+        <p:spPr>
+          <a:xfrm>
+            <a:off x="1134000" y="4888800"/>
+            <a:ext cx="5292000" cy="914400"/>
+          </a:xfrm>
+          <a:prstGeom prst="rect">
+            <a:avLst/>
+          </a:prstGeom>
+          <a:noFill/>
+        </p:spPr>
+        <p:txBody>
+          <a:bodyPr wrap="square">
+            <a:spAutoFit/>
+          </a:bodyPr>
+          <a:lstStyle/>
+          <a:p>
+            <a:pPr algn="ctr"/>
+            <a:r>
+              <a:rPr sz="1800" b="0" i="0">
+                <a:solidFill>
+                  <a:srgbClr val="999999"/>
+                </a:solidFill>
+              </a:rPr>
+              <a:t>（内容由AI生成，仅供参考）</a:t>
+            </a:r>
+          </a:p>
+        </p:txBody>
+      </p:sp>
+    </p:spTree>
+  </p:cSld>
+  <p:clrMapOvr>
+    <a:masterClrMapping/>
+  </p:clrMapOvr>
+</p:sld>
+</file>
+
 <file path=ppt/slides/slide2.xml><?xml version="1.0" encoding="utf-8"?>
 <p:sld xmlns:a="http://schemas.openxmlformats.org/drawingml/2006/main" xmlns:p="http://schemas.openxmlformats.org/presentationml/2006/main" xmlns:r="http://schemas.openxmlformats.org/officeDocument/2006/relationships">
   <p:cSld>

</xml_diff>